<commit_message>
docs: publish verified Phase 0 baseline
</commit_message>
<xml_diff>
--- a/apex-pitch.pptx
+++ b/apex-pitch.pptx
@@ -2417,7 +2417,7 @@
                           <a:ea typeface="Calibri" pitchFamily="34" charset="-122"/>
                           <a:cs typeface="Calibri" pitchFamily="34" charset="-120"/>
                         </a:rPr>
-                        <a:t>Checked against your estimate</a:t>
+                        <a:t>Calibration replay</a:t>
                       </a:r>
                       <a:endParaRPr lang="en-US" sz="1050" dirty="0">
                         <a:latin typeface="Calibri" charset="0"/>
@@ -3228,6 +3228,280 @@
                           <a:ea typeface="Calibri" pitchFamily="34" charset="-122"/>
                           <a:cs typeface="Calibri" pitchFamily="34" charset="-120"/>
                         </a:rPr>
+                        <a:t>700  Pool plumbing</a:t>
+                      </a:r>
+                      <a:endParaRPr lang="en-US" sz="1200" dirty="0">
+                        <a:latin typeface="Calibri" charset="0"/>
+                        <a:ea typeface="Calibri" charset="0"/>
+                        <a:cs typeface="Calibri" charset="0"/>
+                      </a:endParaRPr>
+                    </a:p>
+                  </a:txBody>
+                  <a:tcPr marL="64008" marR="64008" marT="64008" marB="64008" anchor="ctr">
+                    <a:lnL w="9525" cap="flat" cmpd="sng" algn="ctr">
+                      <a:solidFill>
+                        <a:srgbClr val="D4CFC5"/>
+                      </a:solidFill>
+                      <a:prstDash val="solid"/>
+                      <a:round/>
+                      <a:headEnd type="none" w="med" len="med"/>
+                      <a:tailEnd type="none" w="med" len="med"/>
+                    </a:lnL>
+                    <a:lnR w="9525" cap="flat" cmpd="sng" algn="ctr">
+                      <a:solidFill>
+                        <a:srgbClr val="D4CFC5"/>
+                      </a:solidFill>
+                      <a:prstDash val="solid"/>
+                      <a:round/>
+                      <a:headEnd type="none" w="med" len="med"/>
+                      <a:tailEnd type="none" w="med" len="med"/>
+                    </a:lnR>
+                    <a:lnT w="9525" cap="flat" cmpd="sng" algn="ctr">
+                      <a:solidFill>
+                        <a:srgbClr val="D4CFC5"/>
+                      </a:solidFill>
+                      <a:prstDash val="solid"/>
+                      <a:round/>
+                      <a:headEnd type="none" w="med" len="med"/>
+                      <a:tailEnd type="none" w="med" len="med"/>
+                    </a:lnT>
+                    <a:lnB w="9525" cap="flat" cmpd="sng" algn="ctr">
+                      <a:solidFill>
+                        <a:srgbClr val="D4CFC5"/>
+                      </a:solidFill>
+                      <a:prstDash val="solid"/>
+                      <a:round/>
+                      <a:headEnd type="none" w="med" len="med"/>
+                      <a:tailEnd type="none" w="med" len="med"/>
+                    </a:lnB>
+                    <a:solidFill>
+                      <a:srgbClr val="FFFFFF"/>
+                    </a:solidFill>
+                  </a:tcPr>
+                </a:tc>
+                <a:tc>
+                  <a:txBody>
+                    <a:bodyPr/>
+                    <a:lstStyle/>
+                    <a:p>
+                      <a:pPr algn="r" indent="0" marL="0">
+                        <a:buNone/>
+                      </a:pPr>
+                      <a:r>
+                        <a:rPr lang="en-US" sz="1200" dirty="0">
+                          <a:solidFill>
+                            <a:srgbClr val="1B1C1E"/>
+                          </a:solidFill>
+                          <a:latin typeface="Calibri" pitchFamily="34" charset="0"/>
+                          <a:ea typeface="Calibri" pitchFamily="34" charset="-122"/>
+                          <a:cs typeface="Calibri" pitchFamily="34" charset="-120"/>
+                        </a:rPr>
+                        <a:t>$8,101</a:t>
+                      </a:r>
+                      <a:endParaRPr lang="en-US" sz="1200" dirty="0">
+                        <a:latin typeface="Calibri" charset="0"/>
+                        <a:ea typeface="Calibri" charset="0"/>
+                        <a:cs typeface="Calibri" charset="0"/>
+                      </a:endParaRPr>
+                    </a:p>
+                  </a:txBody>
+                  <a:tcPr marL="64008" marR="64008" marT="64008" marB="64008" anchor="ctr">
+                    <a:lnL w="9525" cap="flat" cmpd="sng" algn="ctr">
+                      <a:solidFill>
+                        <a:srgbClr val="D4CFC5"/>
+                      </a:solidFill>
+                      <a:prstDash val="solid"/>
+                      <a:round/>
+                      <a:headEnd type="none" w="med" len="med"/>
+                      <a:tailEnd type="none" w="med" len="med"/>
+                    </a:lnL>
+                    <a:lnR w="9525" cap="flat" cmpd="sng" algn="ctr">
+                      <a:solidFill>
+                        <a:srgbClr val="D4CFC5"/>
+                      </a:solidFill>
+                      <a:prstDash val="solid"/>
+                      <a:round/>
+                      <a:headEnd type="none" w="med" len="med"/>
+                      <a:tailEnd type="none" w="med" len="med"/>
+                    </a:lnR>
+                    <a:lnT w="9525" cap="flat" cmpd="sng" algn="ctr">
+                      <a:solidFill>
+                        <a:srgbClr val="D4CFC5"/>
+                      </a:solidFill>
+                      <a:prstDash val="solid"/>
+                      <a:round/>
+                      <a:headEnd type="none" w="med" len="med"/>
+                      <a:tailEnd type="none" w="med" len="med"/>
+                    </a:lnT>
+                    <a:lnB w="9525" cap="flat" cmpd="sng" algn="ctr">
+                      <a:solidFill>
+                        <a:srgbClr val="D4CFC5"/>
+                      </a:solidFill>
+                      <a:prstDash val="solid"/>
+                      <a:round/>
+                      <a:headEnd type="none" w="med" len="med"/>
+                      <a:tailEnd type="none" w="med" len="med"/>
+                    </a:lnB>
+                    <a:solidFill>
+                      <a:srgbClr val="FFFFFF"/>
+                    </a:solidFill>
+                  </a:tcPr>
+                </a:tc>
+                <a:tc>
+                  <a:txBody>
+                    <a:bodyPr/>
+                    <a:lstStyle/>
+                    <a:p>
+                      <a:pPr algn="r" indent="0" marL="0">
+                        <a:buNone/>
+                      </a:pPr>
+                      <a:r>
+                        <a:rPr lang="en-US" sz="1200" dirty="0">
+                          <a:solidFill>
+                            <a:srgbClr val="1B1C1E"/>
+                          </a:solidFill>
+                          <a:latin typeface="Calibri" pitchFamily="34" charset="0"/>
+                          <a:ea typeface="Calibri" pitchFamily="34" charset="-122"/>
+                          <a:cs typeface="Calibri" pitchFamily="34" charset="-120"/>
+                        </a:rPr>
+                        <a:t>$8,100</a:t>
+                      </a:r>
+                      <a:endParaRPr lang="en-US" sz="1200" dirty="0">
+                        <a:latin typeface="Calibri" charset="0"/>
+                        <a:ea typeface="Calibri" charset="0"/>
+                        <a:cs typeface="Calibri" charset="0"/>
+                      </a:endParaRPr>
+                    </a:p>
+                  </a:txBody>
+                  <a:tcPr marL="64008" marR="64008" marT="64008" marB="64008" anchor="ctr">
+                    <a:lnL w="9525" cap="flat" cmpd="sng" algn="ctr">
+                      <a:solidFill>
+                        <a:srgbClr val="D4CFC5"/>
+                      </a:solidFill>
+                      <a:prstDash val="solid"/>
+                      <a:round/>
+                      <a:headEnd type="none" w="med" len="med"/>
+                      <a:tailEnd type="none" w="med" len="med"/>
+                    </a:lnL>
+                    <a:lnR w="9525" cap="flat" cmpd="sng" algn="ctr">
+                      <a:solidFill>
+                        <a:srgbClr val="D4CFC5"/>
+                      </a:solidFill>
+                      <a:prstDash val="solid"/>
+                      <a:round/>
+                      <a:headEnd type="none" w="med" len="med"/>
+                      <a:tailEnd type="none" w="med" len="med"/>
+                    </a:lnR>
+                    <a:lnT w="9525" cap="flat" cmpd="sng" algn="ctr">
+                      <a:solidFill>
+                        <a:srgbClr val="D4CFC5"/>
+                      </a:solidFill>
+                      <a:prstDash val="solid"/>
+                      <a:round/>
+                      <a:headEnd type="none" w="med" len="med"/>
+                      <a:tailEnd type="none" w="med" len="med"/>
+                    </a:lnT>
+                    <a:lnB w="9525" cap="flat" cmpd="sng" algn="ctr">
+                      <a:solidFill>
+                        <a:srgbClr val="D4CFC5"/>
+                      </a:solidFill>
+                      <a:prstDash val="solid"/>
+                      <a:round/>
+                      <a:headEnd type="none" w="med" len="med"/>
+                      <a:tailEnd type="none" w="med" len="med"/>
+                    </a:lnB>
+                    <a:solidFill>
+                      <a:srgbClr val="FFFFFF"/>
+                    </a:solidFill>
+                  </a:tcPr>
+                </a:tc>
+                <a:tc>
+                  <a:txBody>
+                    <a:bodyPr/>
+                    <a:lstStyle/>
+                    <a:p>
+                      <a:pPr algn="r" indent="0" marL="0">
+                        <a:buNone/>
+                      </a:pPr>
+                      <a:r>
+                        <a:rPr lang="en-US" sz="1200" b="1" dirty="0">
+                          <a:solidFill>
+                            <a:srgbClr val="2F8250"/>
+                          </a:solidFill>
+                          <a:latin typeface="Calibri" pitchFamily="34" charset="0"/>
+                          <a:ea typeface="Calibri" pitchFamily="34" charset="-122"/>
+                          <a:cs typeface="Calibri" pitchFamily="34" charset="-120"/>
+                        </a:rPr>
+                        <a:t>exact</a:t>
+                      </a:r>
+                      <a:endParaRPr lang="en-US" sz="1200" dirty="0">
+                        <a:latin typeface="Calibri" charset="0"/>
+                        <a:ea typeface="Calibri" charset="0"/>
+                        <a:cs typeface="Calibri" charset="0"/>
+                      </a:endParaRPr>
+                    </a:p>
+                  </a:txBody>
+                  <a:tcPr marL="64008" marR="64008" marT="64008" marB="64008" anchor="ctr">
+                    <a:lnL w="9525" cap="flat" cmpd="sng" algn="ctr">
+                      <a:solidFill>
+                        <a:srgbClr val="D4CFC5"/>
+                      </a:solidFill>
+                      <a:prstDash val="solid"/>
+                      <a:round/>
+                      <a:headEnd type="none" w="med" len="med"/>
+                      <a:tailEnd type="none" w="med" len="med"/>
+                    </a:lnL>
+                    <a:lnR w="9525" cap="flat" cmpd="sng" algn="ctr">
+                      <a:solidFill>
+                        <a:srgbClr val="D4CFC5"/>
+                      </a:solidFill>
+                      <a:prstDash val="solid"/>
+                      <a:round/>
+                      <a:headEnd type="none" w="med" len="med"/>
+                      <a:tailEnd type="none" w="med" len="med"/>
+                    </a:lnR>
+                    <a:lnT w="9525" cap="flat" cmpd="sng" algn="ctr">
+                      <a:solidFill>
+                        <a:srgbClr val="D4CFC5"/>
+                      </a:solidFill>
+                      <a:prstDash val="solid"/>
+                      <a:round/>
+                      <a:headEnd type="none" w="med" len="med"/>
+                      <a:tailEnd type="none" w="med" len="med"/>
+                    </a:lnT>
+                    <a:lnB w="9525" cap="flat" cmpd="sng" algn="ctr">
+                      <a:solidFill>
+                        <a:srgbClr val="D4CFC5"/>
+                      </a:solidFill>
+                      <a:prstDash val="solid"/>
+                      <a:round/>
+                      <a:headEnd type="none" w="med" len="med"/>
+                      <a:tailEnd type="none" w="med" len="med"/>
+                    </a:lnB>
+                    <a:solidFill>
+                      <a:srgbClr val="FFFFFF"/>
+                    </a:solidFill>
+                  </a:tcPr>
+                </a:tc>
+              </a:tr>
+              <a:tr h="420624">
+                <a:tc>
+                  <a:txBody>
+                    <a:bodyPr/>
+                    <a:lstStyle/>
+                    <a:p>
+                      <a:pPr algn="l" indent="0" marL="0">
+                        <a:buNone/>
+                      </a:pPr>
+                      <a:r>
+                        <a:rPr lang="en-US" sz="1200" dirty="0">
+                          <a:solidFill>
+                            <a:srgbClr val="1B1C1E"/>
+                          </a:solidFill>
+                          <a:latin typeface="Calibri" pitchFamily="34" charset="0"/>
+                          <a:ea typeface="Calibri" pitchFamily="34" charset="-122"/>
+                          <a:cs typeface="Calibri" pitchFamily="34" charset="-120"/>
+                        </a:rPr>
                         <a:t>800  Pool finishes</a:t>
                       </a:r>
                       <a:endParaRPr lang="en-US" sz="1200" dirty="0">
@@ -3776,7 +4050,7 @@
                           <a:ea typeface="Calibri" pitchFamily="34" charset="-122"/>
                           <a:cs typeface="Calibri" pitchFamily="34" charset="-120"/>
                         </a:rPr>
-                        <a:t>Total</a:t>
+                        <a:t>Modelled codes total</a:t>
                       </a:r>
                       <a:endParaRPr lang="en-US" sz="1200" dirty="0">
                         <a:latin typeface="Calibri" charset="0"/>
@@ -3844,7 +4118,7 @@
                           <a:ea typeface="Calibri" pitchFamily="34" charset="-122"/>
                           <a:cs typeface="Calibri" pitchFamily="34" charset="-120"/>
                         </a:rPr>
-                        <a:t>$61,552</a:t>
+                        <a:t>$69,653</a:t>
                       </a:r>
                       <a:endParaRPr lang="en-US" sz="1200" dirty="0">
                         <a:latin typeface="Calibri" charset="0"/>
@@ -3912,7 +4186,7 @@
                           <a:ea typeface="Calibri" pitchFamily="34" charset="-122"/>
                           <a:cs typeface="Calibri" pitchFamily="34" charset="-120"/>
                         </a:rPr>
-                        <a:t>$61,550</a:t>
+                        <a:t>$69,650</a:t>
                       </a:r>
                       <a:endParaRPr lang="en-US" sz="1200" dirty="0">
                         <a:latin typeface="Calibri" charset="0"/>
@@ -3974,13 +4248,13 @@
                       <a:r>
                         <a:rPr lang="en-US" sz="1200" b="1" dirty="0">
                           <a:solidFill>
-                            <a:srgbClr val="2F8250"/>
+                            <a:srgbClr val="E0901B"/>
                           </a:solidFill>
                           <a:latin typeface="Calibri" pitchFamily="34" charset="0"/>
                           <a:ea typeface="Calibri" pitchFamily="34" charset="-122"/>
                           <a:cs typeface="Calibri" pitchFamily="34" charset="-120"/>
                         </a:rPr>
-                        <a:t>0.0%</a:t>
+                        <a:t>calibrated</a:t>
                       </a:r>
                       <a:endParaRPr lang="en-US" sz="1200" dirty="0">
                         <a:latin typeface="Calibri" charset="0"/>
@@ -4044,8 +4318,8 @@
         </p:nvSpPr>
         <p:spPr>
           <a:xfrm>
-            <a:off x="5943600" y="4480560"/>
-            <a:ext cx="5577840" cy="457200"/>
+            <a:off x="5943600" y="4892040"/>
+            <a:ext cx="5577840" cy="566928"/>
           </a:xfrm>
           <a:prstGeom prst="rect">
             <a:avLst/>
@@ -4058,10 +4332,13 @@
           <a:lstStyle/>
           <a:p>
             <a:pPr indent="0" marL="0">
+              <a:lnSpc>
+                <a:spcPts val="1300"/>
+              </a:lnSpc>
               <a:buNone/>
             </a:pPr>
             <a:r>
-              <a:rPr lang="en-US" sz="1200" i="1" dirty="0">
+              <a:rPr lang="en-US" sz="1050" i="1" dirty="0">
                 <a:solidFill>
                   <a:srgbClr val="54585E"/>
                 </a:solidFill>
@@ -4069,9 +4346,9 @@
                 <a:ea typeface="Calibri" pitchFamily="34" charset="-122"/>
                 <a:cs typeface="Calibri" pitchFamily="34" charset="-120"/>
               </a:rPr>
-              <a:t>Built from the dimensions alone, then compared — not fitted to the answer.</a:t>
-            </a:r>
-            <a:endParaRPr lang="en-US" sz="1200" dirty="0"/>
+              <a:t>Whitaker seeded the current rates. This replay proves arithmetic traceability — predictive accuracy still requires a second completed job.</a:t>
+            </a:r>
+            <a:endParaRPr lang="en-US" sz="1050" dirty="0"/>
           </a:p>
         </p:txBody>
       </p:sp>

</xml_diff>